<commit_message>
Cuadernillos PDF regenerados en español; sin voseo en las presentaciones (verificar-voseo mira los .pptx)
Co-Authored-By: Claude Opus 5.5 <noreply@anthropic.com>
Claude-Session: https://claude.ai/code/session_019kpJgFy6kSQESjpjr1aZo4
</commit_message>
<xml_diff>
--- a/cursos/recursos/desequilibrios-de-material/01-valor-relativo-de-las-piezas.pptx
+++ b/cursos/recursos/desequilibrios-de-material/01-valor-relativo-de-las-piezas.pptx
@@ -3442,7 +3442,7 @@
                 </a:solidFill>
                 <a:latin typeface="Calibri"/>
               </a:rPr>
-              <a:t>Si contamos puntos, las blancas van ligeramente arriba: dama y alfil (12) contra dos alfiles, caballo y cinco peones frente a tres (11, tomando el peón de más como dos puntos). Sin embargo, la posición está perdida para las blancas. El motivo es el primer principio de este curso: la cuenta material es sólo un punto de partida y lo que decide es cómo trabajan las piezas juntas. Las negras tienen un conjunto compacto: el alfil de e6 y el de f6 se protegen mutuamente y al caballo de f4, el rey de g7 cubre f6 y f7, y los peones de c3 y d4 avanzan escoltados por todo el ejército. Ninguna pieza negra puede ser atacada con provecho: la dama blanca no tiene un solo blanco que valga la pena ni una casilla desde la que dar jaques molestos, y el alfil de f1 está reducido a vigilar la promoción. Mientras tanto, las negras disponen de un plan sencillo y mecánico: apoyar ...d3 y ...c2, o antes ganar el alfil con ...d3 y ...Axd3 cuando convenga, sabiendo que la dama sola no puede detener dos peones pasados unidos defendidos por tres piezas menores. Fijate en un detalle importante: las blancas no tienen ni una sola amenaza. Sin amenazas no hay contrajuego, y sin contrajuego el bando con más piezas puede tomarse todo el tiempo del mundo para avanzar. Esta es la enseñanza del ejemplo: cuando una dama se enfrenta a varias piezas menores bien coordinadas, la cantidad de piezas y su armonía pesan más que la calidad individual de la dama. El valor real de cada pieza depende de lo que puede hacer en la posición concreta, no de la tabla de puntos.</a:t>
+              <a:t>Si contamos puntos, las blancas van ligeramente arriba: dama y alfil (12) contra dos alfiles, caballo y cinco peones frente a tres (11, tomando el peón de más como dos puntos). Sin embargo, la posición está perdida para las blancas. El motivo es el primer principio de este curso: la cuenta material es sólo un punto de partida y lo que decide es cómo trabajan las piezas juntas. Las negras tienen un conjunto compacto: el alfil de e6 y el de f6 se protegen mutuamente y al caballo de f4, el rey de g7 cubre f6 y f7, y los peones de c3 y d4 avanzan escoltados por todo el ejército. Ninguna pieza negra puede ser atacada con provecho: la dama blanca no tiene un solo blanco que valga la pena ni una casilla desde la que dar jaques molestos, y el alfil de f1 está reducido a vigilar la promoción. Mientras tanto, las negras disponen de un plan sencillo y mecánico: apoyar ...d3 y ...c2, o antes ganar el alfil con ...d3 y ...Axd3 cuando convenga, sabiendo que la dama sola no puede detener dos peones pasados unidos defendidos por tres piezas menores. Fíjate en un detalle importante: las blancas no tienen ni una sola amenaza. Sin amenazas no hay contrajuego, y sin contrajuego el bando con más piezas puede tomarse todo el tiempo del mundo para avanzar. Esta es la enseñanza del ejemplo: cuando una dama se enfrenta a varias piezas menores bien coordinadas, la cantidad de piezas y su armonía pesan más que la calidad individual de la dama. El valor real de cada pieza depende de lo que puede hacer en la posición concreta, no de la tabla de puntos.</a:t>
             </a:r>
           </a:p>
         </p:txBody>
@@ -3862,7 +3862,7 @@
                 </a:solidFill>
                 <a:latin typeface="Calibri"/>
               </a:rPr>
-              <a:t>•  Antes de evaluar por puntos, preguntate qué puede atacar cada bando: si un bando no tiene blancos, su material vale menos.</a:t>
+              <a:t>•  Antes de evaluar por puntos, pregúntate qué puede atacar cada bando: si un bando no tiene blancos, su material vale menos.</a:t>
             </a:r>
           </a:p>
           <a:p>
@@ -3878,7 +3878,7 @@
                 </a:solidFill>
                 <a:latin typeface="Calibri"/>
               </a:rPr>
-              <a:t>•  Piezas menores que se protegen mutuamente neutralizan a una dama; buscá esa coordinación cuando entregues la dama.</a:t>
+              <a:t>•  Piezas menores que se protegen mutuamente neutralizan a una dama; busca esa coordinación cuando entregues la dama.</a:t>
             </a:r>
           </a:p>
           <a:p>
@@ -4663,7 +4663,7 @@
                 </a:solidFill>
                 <a:latin typeface="Calibri"/>
               </a:rPr>
-              <a:t>•  Antes de aceptar un sacrificio de calidad o de dama, comprobá si la pieza pesada tendrá blancos; si no los tiene, el material extra puede ser inútil.</a:t>
+              <a:t>•  Antes de aceptar un sacrificio de calidad o de dama, comprueba si la pieza pesada tendrá blancos; si no los tiene, el material extra puede ser inútil.</a:t>
             </a:r>
           </a:p>
           <a:p>
@@ -4679,7 +4679,7 @@
                 </a:solidFill>
                 <a:latin typeface="Calibri"/>
               </a:rPr>
-              <a:t>•  Con piezas ligeras contra pieza pesada, ralentizá el juego: cada tempo de maniobra tranquila es tuyo.</a:t>
+              <a:t>•  Con piezas ligeras contra pieza pesada, ralentiza el juego: cada tempo de maniobra tranquila es tuyo.</a:t>
             </a:r>
           </a:p>
           <a:p>
@@ -4695,7 +4695,7 @@
                 </a:solidFill>
                 <a:latin typeface="Calibri"/>
               </a:rPr>
-              <a:t>•  Con la pieza pesada, buscá acelerar: abrí líneas, creá carreras de peones y evitá que el rival termine de construir su casa.</a:t>
+              <a:t>•  Con la pieza pesada, busca acelerar: abre líneas, crea carreras de peones y evita que el rival termine de construir su casa.</a:t>
             </a:r>
           </a:p>
         </p:txBody>
@@ -4838,7 +4838,7 @@
                 </a:solidFill>
                 <a:latin typeface="Calibri"/>
               </a:rPr>
-              <a:t>Las negras tienen sólo caballo y un peón de más contra la dama, un déficit enorme en la cuenta de puntos, y sin embargo esta posición es tablas sin esfuerzo, mueva quien mueva. El ejemplo ilustra el principio de la casa: las ganancias materiales no significan nada si el bando fuerte no puede entrar, y el bando débil sobrevive siempre que su estructura no tenga grietas. Mirá la cadena negra: a6, b5, c4, d5, e6 y g6, h6. Todos los peones están fijados contra los peones blancos, ninguno puede ser atacado por la dama porque cada uno está defendido por otro peón o por el caballo, y el caballo de f5 es una pieza perfecta: apoyado por e6 y g6, bloquea el peón de f4 y vigila d4 y e3. El rey negro sólo tiene que pasear entre f7 y g7, casillas que la dama no puede alcanzar con jaque útil. ¿Qué puede intentar la dama? Ningún peón negro es capturable, no hay jaques que separen al rey del caballo, no existe la posibilidad de un zugzwang porque el rey negro siempre tiene una jugada de espera, y el rey blanco no puede infiltrarse por ninguna casilla. Las blancas tampoco pueden abrir la posición: sus propios peones están bloqueados. La conclusión práctica es doble. Si tenés el bando ligero, antes de contar peones preguntate si podés construir una casa como esta: piezas que se protegen, peones fijados y sin debilidades, rey seguro. Si tenés la dama, evitá a toda costa que el rival cierre la estructura; muchas veces vale la pena entregar uno o dos peones para impedir que se construya la casa, porque una vez cerrada la puerta la ventaja material desaparece.</a:t>
+              <a:t>Las negras tienen sólo caballo y un peón de más contra la dama, un déficit enorme en la cuenta de puntos, y sin embargo esta posición es tablas sin esfuerzo, mueva quien mueva. El ejemplo ilustra el principio de la casa: las ganancias materiales no significan nada si el bando fuerte no puede entrar, y el bando débil sobrevive siempre que su estructura no tenga grietas. Mira la cadena negra: a6, b5, c4, d5, e6 y g6, h6. Todos los peones están fijados contra los peones blancos, ninguno puede ser atacado por la dama porque cada uno está defendido por otro peón o por el caballo, y el caballo de f5 es una pieza perfecta: apoyado por e6 y g6, bloquea el peón de f4 y vigila d4 y e3. El rey negro sólo tiene que pasear entre f7 y g7, casillas que la dama no puede alcanzar con jaque útil. ¿Qué puede intentar la dama? Ningún peón negro es capturable, no hay jaques que separen al rey del caballo, no existe la posibilidad de un zugzwang porque el rey negro siempre tiene una jugada de espera, y el rey blanco no puede infiltrarse por ninguna casilla. Las blancas tampoco pueden abrir la posición: sus propios peones están bloqueados. La conclusión práctica es doble. Si tienes el bando ligero, antes de contar peones pregúntate si puedes construir una casa como esta: piezas que se protegen, peones fijados y sin debilidades, rey seguro. Si tienes la dama, evita a toda costa que el rival cierre la estructura; muchas veces vale la pena entregar uno o dos peones para impedir que se construya la casa, porque una vez cerrada la puerta la ventaja material desaparece.</a:t>
             </a:r>
           </a:p>
         </p:txBody>
@@ -5258,7 +5258,7 @@
                 </a:solidFill>
                 <a:latin typeface="Calibri"/>
               </a:rPr>
-              <a:t>•  Con material de menos, buscá fijar los peones rivales y colocar tus piezas en casillas que se protejan entre sí.</a:t>
+              <a:t>•  Con material de menos, busca fijar los peones rivales y colocar tus piezas en casillas que se protejan entre sí.</a:t>
             </a:r>
           </a:p>
           <a:p>
@@ -5290,7 +5290,7 @@
                 </a:solidFill>
                 <a:latin typeface="Calibri"/>
               </a:rPr>
-              <a:t>•  Con la pieza pesada, actuá rápido: la posición cerrada es tu enemiga, la posición abierta es tu aliada.</a:t>
+              <a:t>•  Con la pieza pesada, actúa rápido: la posición cerrada es tu enemiga, la posición abierta es tu aliada.</a:t>
             </a:r>
           </a:p>
         </p:txBody>
@@ -6067,7 +6067,7 @@
                 </a:solidFill>
                 <a:latin typeface="Calibri"/>
               </a:rPr>
-              <a:t>Pista: Buscá una casilla desde la que ataque dos peones a la vez.</a:t>
+              <a:t>Pista: Busca una casilla desde la que ataque dos peones a la vez.</a:t>
             </a:r>
           </a:p>
         </p:txBody>
@@ -6934,7 +6934,7 @@
                 </a:solidFill>
                 <a:latin typeface="Calibri"/>
               </a:rPr>
-              <a:t>•  Cuando tenés dama contra piezas menores y peones, buscá primero los peones aislados y alejados: son blancos gratuitos.</a:t>
+              <a:t>•  Cuando tienes dama contra piezas menores y peones, busca primero los peones aislados y alejados: son blancos gratuitos.</a:t>
             </a:r>
           </a:p>
           <a:p>
@@ -6950,7 +6950,7 @@
                 </a:solidFill>
                 <a:latin typeface="Calibri"/>
               </a:rPr>
-              <a:t>•  Usá los jaques para ganar tiempo y recolocar la dama, y activá el rey en cuanto el rival deje de tener amenazas.</a:t>
+              <a:t>•  Usa los jaques para ganar tiempo y recolocar la dama, y activa el rey en cuanto el rival deje de tener amenazas.</a:t>
             </a:r>
           </a:p>
           <a:p>
@@ -6966,7 +6966,7 @@
                 </a:solidFill>
                 <a:latin typeface="Calibri"/>
               </a:rPr>
-              <a:t>•  Si sos el bando con menos material, mantené los peones unidos y cerca de tus piezas; un peón suelto es un peón perdido.</a:t>
+              <a:t>•  Si eres el bando con menos material, mantén los peones unidos y cerca de tus piezas; un peón suelto es un peón perdido.</a:t>
             </a:r>
           </a:p>
         </p:txBody>
@@ -8594,7 +8594,7 @@
                 </a:solidFill>
                 <a:latin typeface="Calibri"/>
               </a:rPr>
-              <a:t>•  Evaluá los peones pasados unidos como si fueran una pieza: cuanto más avanzados y mejor apoyados, más valen.</a:t>
+              <a:t>•  Evalúa los peones pasados unidos como si fueran una pieza: cuanto más avanzados y mejor apoyados, más valen.</a:t>
             </a:r>
           </a:p>
           <a:p>
@@ -8610,7 +8610,7 @@
                 </a:solidFill>
                 <a:latin typeface="Calibri"/>
               </a:rPr>
-              <a:t>•  Cuando el rival no tiene amenazas, activá el rey sin miedo; es la pieza que suele decidir estos finales.</a:t>
+              <a:t>•  Cuando el rival no tiene amenazas, activa el rey sin miedo; es la pieza que suele decidir estos finales.</a:t>
             </a:r>
           </a:p>
           <a:p>
@@ -10095,7 +10095,7 @@
                 </a:solidFill>
                 <a:latin typeface="Calibri"/>
               </a:rPr>
-              <a:t>•  Antes de calcular una combinación, preguntate qué estructura de peones queda al final: a veces esa es toda la ganancia.</a:t>
+              <a:t>•  Antes de calcular una combinación, pregúntate qué estructura de peones queda al final: a veces esa es toda la ganancia.</a:t>
             </a:r>
           </a:p>
           <a:p>
@@ -11416,7 +11416,7 @@
                 </a:solidFill>
                 <a:latin typeface="Calibri"/>
               </a:rPr>
-              <a:t>•  Con material de menos, buscá cambiar los peones del flanco donde el rival es más fuerte; sin segunda debilidad no hay victoria.</a:t>
+              <a:t>•  Con material de menos, busca cambiar los peones del flanco donde el rival es más fuerte; sin segunda debilidad no hay victoria.</a:t>
             </a:r>
           </a:p>
           <a:p>
@@ -11432,7 +11432,7 @@
                 </a:solidFill>
                 <a:latin typeface="Calibri"/>
               </a:rPr>
-              <a:t>•  Defendé con rey y caballo juntos, cerca del último peón, y jugá de espera con el caballo.</a:t>
+              <a:t>•  Defiende con rey y caballo juntos, cerca del último peón, y juega de espera con el caballo.</a:t>
             </a:r>
           </a:p>
           <a:p>
@@ -11448,7 +11448,7 @@
                 </a:solidFill>
                 <a:latin typeface="Calibri"/>
               </a:rPr>
-              <a:t>•  Aun en las tablas más simples, revisá los trucos tácticos: un solo descuido (como 1...Cg6??) convierte el final.</a:t>
+              <a:t>•  Aun en las tablas más simples, revisa los trucos tácticos: un solo descuido (como 1...Cg6??) convierte el final.</a:t>
             </a:r>
           </a:p>
         </p:txBody>
@@ -12594,7 +12594,7 @@
                 </a:solidFill>
                 <a:latin typeface="Calibri"/>
               </a:rPr>
-              <a:t>•  Con ventaja material, conservá peones en ambos flancos: son los blancos que tu pieza de largo alcance necesita.</a:t>
+              <a:t>•  Con ventaja material, conserva peones en ambos flancos: son los blancos que tu pieza de largo alcance necesita.</a:t>
             </a:r>
           </a:p>
           <a:p>
@@ -12610,7 +12610,7 @@
                 </a:solidFill>
                 <a:latin typeface="Calibri"/>
               </a:rPr>
-              <a:t>•  Rechazá los cambios de peones que el rival te ofrece en el flanco alejado, aunque parezcan inofensivos.</a:t>
+              <a:t>•  Rechaza los cambios de peones que el rival te ofrece en el flanco alejado, aunque parezcan inofensivos.</a:t>
             </a:r>
           </a:p>
           <a:p>
@@ -12626,7 +12626,7 @@
                 </a:solidFill>
                 <a:latin typeface="Calibri"/>
               </a:rPr>
-              <a:t>•  Contra torre, el caballo y el rey no pueden defender dos flancos; usá la séptima fila para atacar a la vez.</a:t>
+              <a:t>•  Contra torre, el caballo y el rey no pueden defender dos flancos; usa la séptima fila para atacar a la vez.</a:t>
             </a:r>
           </a:p>
         </p:txBody>
@@ -14663,7 +14663,7 @@
                 </a:solidFill>
                 <a:latin typeface="Calibri"/>
               </a:rPr>
-              <a:t>Pista: Buscá la casilla del rey desde la que se acaban los jaques y no se estorba la coronación.</a:t>
+              <a:t>Pista: Busca la casilla del rey desde la que se acaban los jaques y no se estorba la coronación.</a:t>
             </a:r>
           </a:p>
         </p:txBody>
@@ -14884,7 +14884,7 @@
                 </a:solidFill>
                 <a:latin typeface="Calibri"/>
               </a:rPr>
-              <a:t>•  Al elegir entre dos continuaciones igualmente evaluadas, preferí la que deja al rival con el trabajo difícil.</a:t>
+              <a:t>•  Al elegir entre dos continuaciones igualmente evaluadas, prefiere la que deja al rival con el trabajo difícil.</a:t>
             </a:r>
           </a:p>
           <a:p>
@@ -14900,7 +14900,7 @@
                 </a:solidFill>
                 <a:latin typeface="Calibri"/>
               </a:rPr>
-              <a:t>•  Con torre, caballo y peón contra dama, construí primero la casa (piezas que se protegen) y recién después avanzá el peón.</a:t>
+              <a:t>•  Con torre, caballo y peón contra dama, construye primero la casa (piezas que se protegen) y recién después avanza el peón.</a:t>
             </a:r>
           </a:p>
           <a:p>
@@ -14916,7 +14916,7 @@
                 </a:solidFill>
                 <a:latin typeface="Calibri"/>
               </a:rPr>
-              <a:t>•  Con la dama, no confíes en los jaques por inercia: buscá la jugada única que impide la formación ganadora, y si no existe, cambiá material a tiempo.</a:t>
+              <a:t>•  Con la dama, no confíes en los jaques por inercia: busca la jugada única que impide la formación ganadora, y si no existe, cambia material a tiempo.</a:t>
             </a:r>
           </a:p>
         </p:txBody>
@@ -15059,7 +15059,7 @@
                 </a:solidFill>
                 <a:latin typeface="Calibri"/>
               </a:rPr>
-              <a:t>Este principio corrige un reflejo muy común: creer que un peón de más, o un peón pasado, ya garantiza ventaja. En la mayoría de los desequilibrios materiales uno de los bandos se lleva al menos un peón extra, y el alumno tiende a sumarlo automáticamente a su cuenta. La realidad es más matizada. Un peón pasado aislado, sobre todo en el centro, suele ser fácil de bloquear: una pieza se instala delante de él y el peón deja de avanzar; a partir de ese momento puede convertirse incluso en una debilidad que hay que defender. Para que un peón de más pese en la evaluación necesita compañía: una mayoría móvil que lo respalde, un segundo pasado unido (recordá que dos pasados unidos pueden valer una pieza menor y tres, una torre), o al menos la capacidad de atar piezas rivales a su vigilancia. Un peón que no avanza, no crea amenazas y no ata a nadie vale casi nada, aunque en la tabla de puntos sume uno. La ilustración clásica es una posición de Bacrot – Eljanov (Shamkir 2014), que se estudia en la ficha siguiente: las blancas tienen un peón pasado de más en d5 y la posición es, sin embargo, equilibrada, porque el peón está aislado, se bloquea sin esfuerzo y las blancas no tienen ningún plan claro para aprovecharlo. Al evaluar un desequilibrio, por tanto, no preguntes cuántos peones hay de más, sino qué hacen: si avanzan, si se apoyan entre sí, si obligan al rival a gastar piezas en detenerlos. Un solo peón, casi nunca hace nada de eso por sí mismo.</a:t>
+              <a:t>Este principio corrige un reflejo muy común: creer que un peón de más, o un peón pasado, ya garantiza ventaja. En la mayoría de los desequilibrios materiales uno de los bandos se lleva al menos un peón extra, y el alumno tiende a sumarlo automáticamente a su cuenta. La realidad es más matizada. Un peón pasado aislado, sobre todo en el centro, suele ser fácil de bloquear: una pieza se instala delante de él y el peón deja de avanzar; a partir de ese momento puede convertirse incluso en una debilidad que hay que defender. Para que un peón de más pese en la evaluación necesita compañía: una mayoría móvil que lo respalde, un segundo pasado unido (recuerda que dos pasados unidos pueden valer una pieza menor y tres, una torre), o al menos la capacidad de atar piezas rivales a su vigilancia. Un peón que no avanza, no crea amenazas y no ata a nadie vale casi nada, aunque en la tabla de puntos sume uno. La ilustración clásica es una posición de Bacrot – Eljanov (Shamkir 2014), que se estudia en la ficha siguiente: las blancas tienen un peón pasado de más en d5 y la posición es, sin embargo, equilibrada, porque el peón está aislado, se bloquea sin esfuerzo y las blancas no tienen ningún plan claro para aprovecharlo. Al evaluar un desequilibrio, por tanto, no preguntes cuántos peones hay de más, sino qué hacen: si avanzan, si se apoyan entre sí, si obligan al rival a gastar piezas en detenerlos. Un solo peón, casi nunca hace nada de eso por sí mismo.</a:t>
             </a:r>
           </a:p>
         </p:txBody>
@@ -15495,7 +15495,7 @@
                 </a:solidFill>
                 <a:latin typeface="Calibri"/>
               </a:rPr>
-              <a:t>•  Contra un peón pasado aislado, bloquealo con una pieza y seguí jugando con normalidad: en muchos casos la posición es igualada.</a:t>
+              <a:t>•  Contra un peón pasado aislado, bloquéalo con una pieza y sigue jugando con normalidad: en muchos casos la posición es igualada.</a:t>
             </a:r>
           </a:p>
           <a:p>
@@ -15511,7 +15511,7 @@
                 </a:solidFill>
                 <a:latin typeface="Calibri"/>
               </a:rPr>
-              <a:t>•  Cuando aceptes un desequilibrio a cambio de peones, preferí los que estén unidos o formen una mayoría móvil.</a:t>
+              <a:t>•  Cuando aceptes un desequilibrio a cambio de peones, prefiere los que estén unidos o formen una mayoría móvil.</a:t>
             </a:r>
           </a:p>
         </p:txBody>
@@ -17041,7 +17041,7 @@
                 </a:solidFill>
                 <a:latin typeface="Calibri"/>
               </a:rPr>
-              <a:t>•  Antes de contar un peón pasado como ventaja, comprobá si puede ser bloqueado sin esfuerzo; si es así, no lo sumes.</a:t>
+              <a:t>•  Antes de contar un peón pasado como ventaja, comprueba si puede ser bloqueado sin esfuerzo; si es así, no lo sumes.</a:t>
             </a:r>
           </a:p>
           <a:p>
@@ -17057,7 +17057,7 @@
                 </a:solidFill>
                 <a:latin typeface="Calibri"/>
               </a:rPr>
-              <a:t>•  Con alfil contra caballo y pocos peones, buscá posiciones de zugzwang: el alfil puede esperar, el caballo no.</a:t>
+              <a:t>•  Con alfil contra caballo y pocos peones, busca posiciones de zugzwang: el alfil puede esperar, el caballo no.</a:t>
             </a:r>
           </a:p>
           <a:p>
@@ -17073,7 +17073,7 @@
                 </a:solidFill>
                 <a:latin typeface="Calibri"/>
               </a:rPr>
-              <a:t>•  Con el caballo, evitá quedar atado a un peón pasado enemigo; sin jugadas de espera propias, el zugzwang está cerca.</a:t>
+              <a:t>•  Con el caballo, evita quedar atado a un peón pasado enemigo; sin jugadas de espera propias, el zugzwang está cerca.</a:t>
             </a:r>
           </a:p>
         </p:txBody>
@@ -18685,7 +18685,7 @@
                 </a:solidFill>
                 <a:latin typeface="Calibri"/>
               </a:rPr>
-              <a:t>•  Si tenés torre y alfil contra torre, no hay razón para aceptar tablas rápido: exprimí la posición, el rival puede fallar en cualquier momento.</a:t>
+              <a:t>•  Si tienes torre y alfil contra torre, no hay razón para aceptar tablas rápido: exprime la posición, el rival puede fallar en cualquier momento.</a:t>
             </a:r>
           </a:p>
           <a:p>
@@ -18701,7 +18701,7 @@
                 </a:solidFill>
                 <a:latin typeface="Calibri"/>
               </a:rPr>
-              <a:t>•  Como defensor, mantené el rey lejos de la banda y usá la torre para jaquear de costado; cuando dudes entre mover el rey o la torre, revisá si el rey queda frente al rey rival.</a:t>
+              <a:t>•  Como defensor, mantén el rey lejos de la banda y usa la torre para jaquear de costado; cuando dudes entre mover el rey o la torre, revisa si el rey queda frente al rey rival.</a:t>
             </a:r>
           </a:p>
           <a:p>
@@ -18717,7 +18717,7 @@
                 </a:solidFill>
                 <a:latin typeface="Calibri"/>
               </a:rPr>
-              <a:t>•  La coordinación torre-alfil es una de las más eficaces del ajedrez: valorá esa pareja al decidir qué piezas cambiar.</a:t>
+              <a:t>•  La coordinación torre-alfil es una de las más eficaces del ajedrez: valora esa pareja al decidir qué piezas cambiar.</a:t>
             </a:r>
           </a:p>
         </p:txBody>
@@ -19319,7 +19319,7 @@
                 </a:solidFill>
                 <a:latin typeface="Calibri"/>
               </a:rPr>
-              <a:t>Pista: Pensá en la distancia y en tener dos direcciones de jaque disponibles.</a:t>
+              <a:t>Pista: Piensa en la distancia y en tener dos direcciones de jaque disponibles.</a:t>
             </a:r>
           </a:p>
         </p:txBody>
@@ -20509,7 +20509,7 @@
                 </a:solidFill>
                 <a:latin typeface="Calibri"/>
               </a:rPr>
-              <a:t>•  Defendiendo torre contra torre y caballo, colocá la torre en el rincón más lejano y mantené las dos direcciones de jaque; no la acerques nunca sin motivo.</a:t>
+              <a:t>•  Defendiendo torre contra torre y caballo, coloca la torre en el rincón más lejano y mantén las dos direcciones de jaque; no la acerques nunca sin motivo.</a:t>
             </a:r>
           </a:p>
           <a:p>
@@ -20525,7 +20525,7 @@
                 </a:solidFill>
                 <a:latin typeface="Calibri"/>
               </a:rPr>
-              <a:t>•  Como atacante, acercá las tres piezas y esperá el descuido: el mate en la esquina aparece cuando la torre rival pierde la distancia.</a:t>
+              <a:t>•  Como atacante, acerca las tres piezas y esperá el descuido: el mate en la esquina aparece cuando la torre rival pierde la distancia.</a:t>
             </a:r>
           </a:p>
           <a:p>
@@ -22476,7 +22476,7 @@
                 </a:solidFill>
                 <a:latin typeface="Calibri"/>
               </a:rPr>
-              <a:t>•  Con dama y caballo contra dama, escondé el rey junto al caballo, agotá los jaques y recién después empezá a jaquear vos.</a:t>
+              <a:t>•  Con dama y caballo contra dama, esconde el rey junto al caballo, agota los jaques y recién después empieza a jaquear tú.</a:t>
             </a:r>
           </a:p>
           <a:p>
@@ -22492,7 +22492,7 @@
                 </a:solidFill>
                 <a:latin typeface="Calibri"/>
               </a:rPr>
-              <a:t>•  Buscá siempre la casilla de caballo que combine defensa del rey con amenazas de horquilla.</a:t>
+              <a:t>•  Busca siempre la casilla de caballo que combine defensa del rey con amenazas de horquilla.</a:t>
             </a:r>
           </a:p>
           <a:p>
@@ -22508,7 +22508,7 @@
                 </a:solidFill>
                 <a:latin typeface="Calibri"/>
               </a:rPr>
-              <a:t>•  Como defensor, antes de cada jugada de rey revisá los jaques de caballo posibles: un solo descuido decide.</a:t>
+              <a:t>•  Como defensor, antes de cada jugada de rey revisa los jaques de caballo posibles: un solo descuido decide.</a:t>
             </a:r>
           </a:p>
         </p:txBody>
@@ -23654,7 +23654,7 @@
                 </a:solidFill>
                 <a:latin typeface="Calibri"/>
               </a:rPr>
-              <a:t>•  Los valores 1-3-3-5-9 son el punto de partida, no la evaluación final: mirá siempre coordinación, estabilidad y estructura.</a:t>
+              <a:t>•  Los valores 1-3-3-5-9 son el punto de partida, no la evaluación final: mira siempre coordinación, estabilidad y estructura.</a:t>
             </a:r>
           </a:p>
           <a:p>
@@ -23686,7 +23686,7 @@
                 </a:solidFill>
                 <a:latin typeface="Calibri"/>
               </a:rPr>
-              <a:t>•  Antes de entregar calidad o pieza, preguntate si el bando pesado va a tener objetivos concretos para atacar.</a:t>
+              <a:t>•  Antes de entregar calidad o pieza, pregúntate si el bando pesado va a tener objetivos concretos para atacar.</a:t>
             </a:r>
           </a:p>
           <a:p>
@@ -23718,7 +23718,7 @@
                 </a:solidFill>
                 <a:latin typeface="Calibri"/>
               </a:rPr>
-              <a:t>•  Si defendés con desventaja material, cambiá peones y reducí el juego a un solo flanco.</a:t>
+              <a:t>•  Si defiendes con desventaja material, cambia peones y reduce el juego a un solo flanco.</a:t>
             </a:r>
           </a:p>
           <a:p>
@@ -23734,7 +23734,7 @@
                 </a:solidFill>
                 <a:latin typeface="Calibri"/>
               </a:rPr>
-              <a:t>•  No te apures a resolver la posición: mejorá gradualmente y dejá que el desgaste juegue a tu favor.</a:t>
+              <a:t>•  No te apures a resolver la posición: mejora gradualmente y deja que el desgaste juegue a tu favor.</a:t>
             </a:r>
           </a:p>
           <a:p>
@@ -23750,7 +23750,7 @@
                 </a:solidFill>
                 <a:latin typeface="Calibri"/>
               </a:rPr>
-              <a:t>•  Una evaluación de 0.00 no significa 'tablas fáciles para los dos': valorá también quién juega más cómodo.</a:t>
+              <a:t>•  Una evaluación de 0.00 no significa 'tablas fáciles para los dos': valora también quién juega más cómodo.</a:t>
             </a:r>
           </a:p>
         </p:txBody>
@@ -23893,7 +23893,7 @@
                 </a:solidFill>
                 <a:latin typeface="Calibri"/>
               </a:rPr>
-              <a:t>•  Defendiendo con dama contra dama y alfil, la prioridad absoluta es reunir rey y dama; elegí la casilla del rey pensando en acercarte a ella.</a:t>
+              <a:t>•  Defendiendo con dama contra dama y alfil, la prioridad absoluta es reunir rey y dama; elige la casilla del rey pensando en acercarte a ella.</a:t>
             </a:r>
           </a:p>
           <a:p>
@@ -23925,7 +23925,7 @@
                 </a:solidFill>
                 <a:latin typeface="Calibri"/>
               </a:rPr>
-              <a:t>•  Como atacante, buscá jugadas tranquilas de alfil que quiten casillas al rey antes de dar el siguiente jaque.</a:t>
+              <a:t>•  Como atacante, busca jugadas tranquilas de alfil que quiten casillas al rey antes de dar el siguiente jaque.</a:t>
             </a:r>
           </a:p>
         </p:txBody>
@@ -24068,7 +24068,7 @@
                 </a:solidFill>
                 <a:latin typeface="Calibri"/>
               </a:rPr>
-              <a:t>Armá en el tablero los ejemplos de dama contra pieza menor de esta lección y jugalos contra el motor primero con el bando pesado y después con el ligero, cronometrando cuánto tarda cada uno en crear amenazas reales. Después repasá la partida Carlsen–Nepomniachtchi (Dubái 2021, partida 6) buscando el momento exacto en que la evaluación numérica todavía era modesta pero la posición ya era mucho más difícil de defender que de atacar.</a:t>
+              <a:t>Arma en el tablero los ejemplos de dama contra pieza menor de esta lección y juégalos contra el motor primero con el bando pesado y después con el ligero, cronometrando cuánto tarda cada uno en crear amenazas reales. Después repasa la partida Carlsen–Nepomniachtchi (Dubái 2021, partida 6) buscando el momento exacto en que la evaluación numérica todavía era modesta pero la posición ya era mucho más difícil de defender que de atacar.</a:t>
             </a:r>
           </a:p>
           <a:p>
@@ -24100,7 +24100,7 @@
                 </a:solidFill>
                 <a:latin typeface="Calibri"/>
               </a:rPr>
-              <a:t>En la página del curso podés recorrer cada partida con los comentarios, adivinar las jugadas clave en el tablero y continuar cualquier posición contra el motor (Stockfish). La hoja de ejercicios en PDF reúne los momentos clave de esta lección para resolver sin tablero.</a:t>
+              <a:t>En la página del curso puedes recorrer cada partida con los comentarios, adivinar las jugadas clave en el tablero y continuar cualquier posición contra el motor (Stockfish). La hoja de ejercicios en PDF reúne los momentos clave de esta lección para resolver sin tablero.</a:t>
             </a:r>
           </a:p>
         </p:txBody>
@@ -24139,7 +24139,7 @@
                 </a:solidFill>
                 <a:latin typeface="Calibri"/>
               </a:rPr>
-              <a:t>•  Primero recorré la partida completa leyendo los comentarios.</a:t>
+              <a:t>•  Primero recorre la partida completa leyendo los comentarios.</a:t>
             </a:r>
           </a:p>
           <a:p>
@@ -24155,7 +24155,7 @@
                 </a:solidFill>
                 <a:latin typeface="Calibri"/>
               </a:rPr>
-              <a:t>•  Después hacé el modo "adivinar las jugadas clave" hasta acertar todas.</a:t>
+              <a:t>•  Después haz el modo "adivinar las jugadas clave" hasta acertar todas.</a:t>
             </a:r>
           </a:p>
           <a:p>
@@ -24171,7 +24171,7 @@
                 </a:solidFill>
                 <a:latin typeface="Calibri"/>
               </a:rPr>
-              <a:t>•  Por último respondé el cuestionario y anotá con tus palabras las reglas de la lección.</a:t>
+              <a:t>•  Por último responde el cuestionario y anota con tus palabras las reglas de la lección.</a:t>
             </a:r>
           </a:p>
         </p:txBody>

</xml_diff>

<commit_message>
«Tenedor», nunca «horquilla»: en todo el sitio y en lo que se escriba después (#786)
Unas 1.850 apariciones cambiadas con el género ajustado, los PDF y presentaciones regenerados o corregidos, verificar-vocabulario.py para que la palabra no vuelva, y «Mejorar informe» (versión 3 desplegada) dice siempre «tenedor». Los identificadores internos no cambian.

Co-Authored-By: Claude Opus 5.5 <noreply@anthropic.com>
Claude-Session: https://claude.ai/code/session_01JDX4nJSAbz5H7h372fFPc2
</commit_message>
<xml_diff>
--- a/cursos/recursos/desequilibrios-de-material/01-valor-relativo-de-las-piezas.pptx
+++ b/cursos/recursos/desequilibrios-de-material/01-valor-relativo-de-las-piezas.pptx
@@ -8769,7 +8769,7 @@
                 </a:solidFill>
                 <a:latin typeface="Calibri"/>
               </a:rPr>
-              <a:t>Las blancas acaban de jugar 31.c4 y amenazan Cd5+ seguido de f4, lo que dejaría al peón de e6 como un monstruo. Las negras responden con una pequeña combinación que no gana material: entregan el caballo en c4 y lo recuperan con las horquillas de peón ...b5 y ...d5. Lo importante no es el balance de piezas, que termina igualado, sino la transformación de la estructura: las negras quedan con dos peones pasados unidos en b5 y c5, mientras que los peones de más de las blancas en e6 y f3 están desconectados y no aportan nada. El final se gana casi solo empujando ...c4-c3-c2 y luego ...b4. La partida enseña a mirar la distribución de peones antes que la cuenta de material, y a valorar los pasados unidos como la fuerza que realmente son.</a:t>
+              <a:t>Las blancas acaban de jugar 31.c4 y amenazan Cd5+ seguido de f4, lo que dejaría al peón de e6 como un monstruo. Las negras responden con una pequeña combinación que no gana material: entregan el caballo en c4 y lo recuperan con los tenedores de peón ...b5 y ...d5. Lo importante no es el balance de piezas, que termina igualado, sino la transformación de la estructura: las negras quedan con dos peones pasados unidos en b5 y c5, mientras que los peones de más de las blancas en e6 y f3 están desconectados y no aportan nada. El final se gana casi solo empujando ...c4-c3-c2 y luego ...b4. La partida enseña a mirar la distribución de peones antes que la cuenta de material, y a valorar los pasados unidos como la fuerza que realmente son.</a:t>
             </a:r>
           </a:p>
         </p:txBody>
@@ -9228,7 +9228,7 @@
                 </a:solidFill>
                 <a:latin typeface="Calibri"/>
               </a:rPr>
-              <a:t>Pista: Una entrega temporal: el caballo se recupera con dos horquillas de peón.</a:t>
+              <a:t>Pista: Una entrega temporal: el caballo se recupera con dos tenedores de peón.</a:t>
             </a:r>
           </a:p>
         </p:txBody>
@@ -20684,7 +20684,7 @@
                 </a:solidFill>
                 <a:latin typeface="Calibri"/>
               </a:rPr>
-              <a:t>Dama y caballo contra dama es tablas en la mayoría de los casos, pero es uno de los finales más incómodos de defender: el caballo es un defensor excelente contra los jaques, así que al bando débil se le acaban rápido los jaques perpetuos y el bando fuerte puede maniobrar sin riesgo creando amenazas de horquilla y de mate. Spassky, sin nada que perder, fue paseando su rey hacia la protección del caballo, esperó a que los jaques se agotaran y comenzó a jaquear él mismo. Karpov, uno de los mejores defensores de la historia, aguantó durante quince jugadas hasta que un solo descuido (83...Rd8??) permitió un jaque de caballo que ganaba la dama. La lección: dama y caballo forman una pareja peligrosa, y un final objetivamente igualado puede ser un campo minado para quien defiende.</a:t>
+              <a:t>Dama y caballo contra dama es tablas en la mayoría de los casos, pero es uno de los finales más incómodos de defender: el caballo es un defensor excelente contra los jaques, así que al bando débil se le acaban rápido los jaques perpetuos y el bando fuerte puede maniobrar sin riesgo creando amenazas de tenedor y de mate. Spassky, sin nada que perder, fue paseando su rey hacia la protección del caballo, esperó a que los jaques se agotaran y comenzó a jaquear él mismo. Karpov, uno de los mejores defensores de la historia, aguantó durante quince jugadas hasta que un solo descuido (83...Rd8??) permitió un jaque de caballo que ganaba la dama. La lección: dama y caballo forman una pareja peligrosa, y un final objetivamente igualado puede ser un campo minado para quien defiende.</a:t>
             </a:r>
           </a:p>
         </p:txBody>
@@ -20723,7 +20723,7 @@
                 </a:solidFill>
                 <a:latin typeface="Calibri"/>
               </a:rPr>
-              <a:t>•  El caballo tapa jaques y crea horquillas: junto a la dama, hace que los jaques del defensor se agoten rápido.</a:t>
+              <a:t>•  El caballo tapa jaques y crea tenedores: junto a la dama, hace que los jaques del defensor se agoten rápido.</a:t>
             </a:r>
           </a:p>
           <a:p>
@@ -21609,7 +21609,7 @@
                 </a:solidFill>
                 <a:latin typeface="Calibri"/>
               </a:rPr>
-              <a:t>Pista: Una casilla central desde la que el caballo proteja al rey y amenace horquillas.</a:t>
+              <a:t>Pista: Una casilla central desde la que el caballo proteja al rey y amenace tenedores.</a:t>
             </a:r>
           </a:p>
         </p:txBody>
@@ -21687,7 +21687,7 @@
                 </a:solidFill>
                 <a:latin typeface="Calibri"/>
               </a:rPr>
-              <a:t>75.Cc5 centraliza el caballo: cubre d7, e6, b7 y a6, protege al rey y crea amenazas de horquilla. Tras 75...Dg4+ 76.Rb5 las negras ya no tienen jaques y deben jugar con extremo cuidado.</a:t>
+              <a:t>75.Cc5 centraliza el caballo: cubre d7, e6, b7 y a6, protege al rey y crea amenazas de tenedor. Tras 75...Dg4+ 76.Rb5 las negras ya no tienen jaques y deben jugar con extremo cuidado.</a:t>
             </a:r>
           </a:p>
         </p:txBody>
@@ -22492,7 +22492,7 @@
                 </a:solidFill>
                 <a:latin typeface="Calibri"/>
               </a:rPr>
-              <a:t>•  Busca siempre la casilla de caballo que combine defensa del rey con amenazas de horquilla.</a:t>
+              <a:t>•  Busca siempre la casilla de caballo que combine defensa del rey con amenazas de tenedor.</a:t>
             </a:r>
           </a:p>
           <a:p>
@@ -22651,7 +22651,7 @@
                 </a:solidFill>
                 <a:latin typeface="Calibri"/>
               </a:rPr>
-              <a:t>Dama y alfil contra dama es tablas en cerca del 80% de los casos, más aún que dama y caballo contra dama, porque el alfil no crea horquillas y el bando fuerte casi no tiene amenazas. La receta del defensor es simple: mantener dama y rey juntos. En esta partida, la única entre grandes maestros en partida clásica que se perdió con este material, el problema fue justamente que la dama blanca estaba en h8, lejísimos de su rey, y Muzychuk eligió la casilla incorrecta para él. Tras 86.Ra2?? el rey quedó en la esquina, y Harikrishna encontró 88...Ae5!, un recurso casi milagroso que corta la diagonal larga, quita a1 y b2 al rey y deja a la dama blanca sin posibilidad de acudir. Con la dama negra jaqueando desde a4, b3 y d1, el mate fue forzado. El ejemplo muestra que una victoria en este final depende de circunstancias muy particulares, y que 86.Rc2!, acercando el rey a la dama, habría sido tablas sin ningún esfuerzo.</a:t>
+              <a:t>Dama y alfil contra dama es tablas en cerca del 80% de los casos, más aún que dama y caballo contra dama, porque el alfil no crea tenedores y el bando fuerte casi no tiene amenazas. La receta del defensor es simple: mantener dama y rey juntos. En esta partida, la única entre grandes maestros en partida clásica que se perdió con este material, el problema fue justamente que la dama blanca estaba en h8, lejísimos de su rey, y Muzychuk eligió la casilla incorrecta para él. Tras 86.Ra2?? el rey quedó en la esquina, y Harikrishna encontró 88...Ae5!, un recurso casi milagroso que corta la diagonal larga, quita a1 y b2 al rey y deja a la dama blanca sin posibilidad de acudir. Con la dama negra jaqueando desde a4, b3 y d1, el mate fue forzado. El ejemplo muestra que una victoria en este final depende de circunstancias muy particulares, y que 86.Rc2!, acercando el rey a la dama, habría sido tablas sin ningún esfuerzo.</a:t>
             </a:r>
           </a:p>
         </p:txBody>
@@ -22722,7 +22722,7 @@
                 </a:solidFill>
                 <a:latin typeface="Calibri"/>
               </a:rPr>
-              <a:t>•  A diferencia del caballo, el alfil no da horquillas, así que las victorias en este final son excepcionales y dependen de errores concretos.</a:t>
+              <a:t>•  A diferencia del caballo, el alfil no da tenedores, así que las victorias en este final son excepcionales y dependen de errores concretos.</a:t>
             </a:r>
           </a:p>
         </p:txBody>

</xml_diff>